<commit_message>
Correction d'erreurs de frappe
</commit_message>
<xml_diff>
--- a/10. Dérivation/10_Dérivation.pptx
+++ b/10. Dérivation/10_Dérivation.pptx
@@ -1799,7 +1799,7 @@
           <a:p>
             <a:fld id="{4D7BB345-1F45-4209-89C2-CEF6D1D81871}" type="datetimeFigureOut">
               <a:rPr lang="fr-FR" smtClean="0"/>
-              <a:t>16/02/2026</a:t>
+              <a:t>27/03/2026</a:t>
             </a:fld>
             <a:endParaRPr lang="fr-FR"/>
           </a:p>
@@ -10873,12 +10873,12 @@
           <a:graphicData uri="http://schemas.openxmlformats.org/presentationml/2006/ole">
             <mc:AlternateContent xmlns:mc="http://schemas.openxmlformats.org/markup-compatibility/2006">
               <mc:Choice xmlns:v="urn:schemas-microsoft-com:vml" Requires="v">
-                <p:oleObj spid="_x0000_s7180" name="Worksheet" r:id="rId3" imgW="14849435" imgH="1971734" progId="Excel.Sheet.12">
+                <p:oleObj name="Worksheet" r:id="rId2" imgW="14849435" imgH="1971734" progId="Excel.Sheet.12">
                   <p:embed/>
                 </p:oleObj>
               </mc:Choice>
               <mc:Fallback>
-                <p:oleObj name="Worksheet" r:id="rId3" imgW="14849435" imgH="1971734" progId="Excel.Sheet.12">
+                <p:oleObj name="Worksheet" r:id="rId2" imgW="14849435" imgH="1971734" progId="Excel.Sheet.12">
                   <p:embed/>
                   <p:pic>
                     <p:nvPicPr>
@@ -10887,7 +10887,7 @@
                       <p:nvPr/>
                     </p:nvPicPr>
                     <p:blipFill>
-                      <a:blip r:embed="rId4"/>
+                      <a:blip r:embed="rId3"/>
                       <a:stretch>
                         <a:fillRect/>
                       </a:stretch>
@@ -11350,8 +11350,8 @@
           </a:p>
         </p:txBody>
       </p:sp>
-      <mc:AlternateContent xmlns:mc="http://schemas.openxmlformats.org/markup-compatibility/2006">
-        <mc:Choice xmlns:a14="http://schemas.microsoft.com/office/drawing/2010/main" Requires="a14">
+      <mc:AlternateContent xmlns:mc="http://schemas.openxmlformats.org/markup-compatibility/2006" xmlns:a14="http://schemas.microsoft.com/office/drawing/2010/main">
+        <mc:Choice Requires="a14">
           <p:sp>
             <p:nvSpPr>
               <p:cNvPr id="136" name="TextShape 2">
@@ -11496,7 +11496,7 @@
                     <m:f>
                       <m:fPr>
                         <m:ctrlPr>
-                          <a:rPr lang="fr-FR" sz="2400" spc="-1" smtClean="0">
+                          <a:rPr lang="fr-FR" sz="2400" i="1" spc="-1" smtClean="0">
                             <a:solidFill>
                               <a:srgbClr val="376092"/>
                             </a:solidFill>
@@ -11635,7 +11635,7 @@
             </p:txBody>
           </p:sp>
         </mc:Choice>
-        <mc:Fallback>
+        <mc:Fallback xmlns="">
           <p:sp>
             <p:nvSpPr>
               <p:cNvPr id="136" name="TextShape 2">
@@ -11839,8 +11839,8 @@
           </a:p>
         </p:txBody>
       </p:sp>
-      <mc:AlternateContent xmlns:mc="http://schemas.openxmlformats.org/markup-compatibility/2006">
-        <mc:Choice xmlns:a14="http://schemas.microsoft.com/office/drawing/2010/main" Requires="a14">
+      <mc:AlternateContent xmlns:mc="http://schemas.openxmlformats.org/markup-compatibility/2006" xmlns:a14="http://schemas.microsoft.com/office/drawing/2010/main">
+        <mc:Choice Requires="a14">
           <p:sp>
             <p:nvSpPr>
               <p:cNvPr id="136" name="TextShape 2">
@@ -12303,7 +12303,7 @@
             </p:txBody>
           </p:sp>
         </mc:Choice>
-        <mc:Fallback>
+        <mc:Fallback xmlns="">
           <p:sp>
             <p:nvSpPr>
               <p:cNvPr id="136" name="TextShape 2">
@@ -12444,8 +12444,8 @@
           </a:p>
         </p:txBody>
       </p:sp>
-      <mc:AlternateContent xmlns:mc="http://schemas.openxmlformats.org/markup-compatibility/2006">
-        <mc:Choice xmlns:a14="http://schemas.microsoft.com/office/drawing/2010/main" Requires="a14">
+      <mc:AlternateContent xmlns:mc="http://schemas.openxmlformats.org/markup-compatibility/2006" xmlns:a14="http://schemas.microsoft.com/office/drawing/2010/main">
+        <mc:Choice Requires="a14">
           <p:sp>
             <p:nvSpPr>
               <p:cNvPr id="136" name="TextShape 2">
@@ -12774,7 +12774,7 @@
             </p:txBody>
           </p:sp>
         </mc:Choice>
-        <mc:Fallback>
+        <mc:Fallback xmlns="">
           <p:sp>
             <p:nvSpPr>
               <p:cNvPr id="136" name="TextShape 2">
@@ -12850,7 +12850,7 @@
           <a:graphicData uri="http://schemas.openxmlformats.org/presentationml/2006/ole">
             <mc:AlternateContent xmlns:mc="http://schemas.openxmlformats.org/markup-compatibility/2006">
               <mc:Choice xmlns:v="urn:schemas-microsoft-com:vml" Requires="v">
-                <p:oleObj spid="_x0000_s12295" name="Worksheet" r:id="rId4" imgW="6667573" imgH="2486084" progId="Excel.Sheet.12">
+                <p:oleObj name="Worksheet" r:id="rId4" imgW="6667573" imgH="2486084" progId="Excel.Sheet.12">
                   <p:embed/>
                 </p:oleObj>
               </mc:Choice>
@@ -12885,6 +12885,66 @@
           </a:graphicData>
         </a:graphic>
       </p:graphicFrame>
+      <p:pic>
+        <p:nvPicPr>
+          <p:cNvPr id="12293" name="Connecteur droit avec flèche 31">
+            <a:extLst>
+              <a:ext uri="{FF2B5EF4-FFF2-40B4-BE49-F238E27FC236}">
+                <a16:creationId xmlns:a16="http://schemas.microsoft.com/office/drawing/2014/main" id="{D8A598EF-ABBB-F2DC-CA1F-38CFE18D09B8}"/>
+              </a:ext>
+            </a:extLst>
+          </p:cNvPr>
+          <p:cNvPicPr>
+            <a:picLocks noChangeAspect="1" noChangeArrowheads="1"/>
+          </p:cNvPicPr>
+          <p:nvPr/>
+        </p:nvPicPr>
+        <p:blipFill>
+          <a:blip r:embed="rId5">
+            <a:extLst>
+              <a:ext uri="{28A0092B-C50C-407E-A947-70E740481C1C}">
+                <a14:useLocalDpi xmlns:a14="http://schemas.microsoft.com/office/drawing/2010/main" val="0"/>
+              </a:ext>
+            </a:extLst>
+          </a:blip>
+          <a:srcRect/>
+          <a:stretch>
+            <a:fillRect/>
+          </a:stretch>
+        </p:blipFill>
+        <p:spPr bwMode="auto">
+          <a:xfrm>
+            <a:off x="561975" y="438150"/>
+            <a:ext cx="3124200" cy="1247775"/>
+          </a:xfrm>
+          <a:prstGeom prst="rect">
+            <a:avLst/>
+          </a:prstGeom>
+          <a:noFill/>
+          <a:ln>
+            <a:noFill/>
+          </a:ln>
+          <a:extLst>
+            <a:ext uri="{909E8E84-426E-40DD-AFC4-6F175D3DCCD1}">
+              <a14:hiddenFill xmlns:a14="http://schemas.microsoft.com/office/drawing/2010/main">
+                <a:solidFill>
+                  <a:srgbClr val="FFFFFF"/>
+                </a:solidFill>
+              </a14:hiddenFill>
+            </a:ext>
+            <a:ext uri="{91240B29-F687-4F45-9708-019B960494DF}">
+              <a14:hiddenLine xmlns:a14="http://schemas.microsoft.com/office/drawing/2010/main" w="9525">
+                <a:solidFill>
+                  <a:srgbClr val="000000"/>
+                </a:solidFill>
+                <a:miter lim="800000"/>
+                <a:headEnd/>
+                <a:tailEnd/>
+              </a14:hiddenLine>
+            </a:ext>
+          </a:extLst>
+        </p:spPr>
+      </p:pic>
     </p:spTree>
     <p:extLst>
       <p:ext uri="{BB962C8B-B14F-4D97-AF65-F5344CB8AC3E}">
@@ -12978,8 +13038,8 @@
           </a:p>
         </p:txBody>
       </p:sp>
-      <mc:AlternateContent xmlns:mc="http://schemas.openxmlformats.org/markup-compatibility/2006">
-        <mc:Choice xmlns:a14="http://schemas.microsoft.com/office/drawing/2010/main" Requires="a14">
+      <mc:AlternateContent xmlns:mc="http://schemas.openxmlformats.org/markup-compatibility/2006" xmlns:a14="http://schemas.microsoft.com/office/drawing/2010/main">
+        <mc:Choice Requires="a14">
           <p:sp>
             <p:nvSpPr>
               <p:cNvPr id="136" name="TextShape 2">
@@ -13601,7 +13661,7 @@
             </p:txBody>
           </p:sp>
         </mc:Choice>
-        <mc:Fallback>
+        <mc:Fallback xmlns="">
           <p:sp>
             <p:nvSpPr>
               <p:cNvPr id="136" name="TextShape 2">
@@ -15998,8 +16058,8 @@
           </a:p>
         </p:txBody>
       </p:sp>
-      <mc:AlternateContent xmlns:mc="http://schemas.openxmlformats.org/markup-compatibility/2006">
-        <mc:Choice xmlns:a14="http://schemas.microsoft.com/office/drawing/2010/main" Requires="a14">
+      <mc:AlternateContent xmlns:mc="http://schemas.openxmlformats.org/markup-compatibility/2006" xmlns:a14="http://schemas.microsoft.com/office/drawing/2010/main">
+        <mc:Choice Requires="a14">
           <p:sp>
             <p:nvSpPr>
               <p:cNvPr id="136" name="TextShape 2">
@@ -16223,7 +16283,7 @@
                     <m:d>
                       <m:dPr>
                         <m:ctrlPr>
-                          <a:rPr lang="fr-FR" sz="2400" b="0" i="0" spc="-1" dirty="0" smtClean="0">
+                          <a:rPr lang="fr-FR" sz="2400" b="0" i="1" spc="-1" dirty="0" smtClean="0">
                             <a:solidFill>
                               <a:srgbClr val="376092"/>
                             </a:solidFill>
@@ -16258,7 +16318,7 @@
                     <m:f>
                       <m:fPr>
                         <m:ctrlPr>
-                          <a:rPr lang="fr-FR" sz="2400" spc="-1" dirty="0" smtClean="0">
+                          <a:rPr lang="fr-FR" sz="2400" i="1" spc="-1" dirty="0" smtClean="0">
                             <a:solidFill>
                               <a:srgbClr val="376092"/>
                             </a:solidFill>
@@ -16408,7 +16468,7 @@
             </p:txBody>
           </p:sp>
         </mc:Choice>
-        <mc:Fallback>
+        <mc:Fallback xmlns="">
           <p:sp>
             <p:nvSpPr>
               <p:cNvPr id="136" name="TextShape 2">
@@ -17495,8 +17555,8 @@
           </a:p>
         </p:txBody>
       </p:sp>
-      <mc:AlternateContent xmlns:mc="http://schemas.openxmlformats.org/markup-compatibility/2006">
-        <mc:Choice xmlns:a14="http://schemas.microsoft.com/office/drawing/2010/main" Requires="a14">
+      <mc:AlternateContent xmlns:mc="http://schemas.openxmlformats.org/markup-compatibility/2006" xmlns:a14="http://schemas.microsoft.com/office/drawing/2010/main">
+        <mc:Choice Requires="a14">
           <p:sp>
             <p:nvSpPr>
               <p:cNvPr id="136" name="TextShape 2">
@@ -17755,7 +17815,7 @@
             </p:txBody>
           </p:sp>
         </mc:Choice>
-        <mc:Fallback>
+        <mc:Fallback xmlns="">
           <p:sp>
             <p:nvSpPr>
               <p:cNvPr id="136" name="TextShape 2">
@@ -18254,8 +18314,8 @@
           </a:p>
         </p:txBody>
       </p:sp>
-      <mc:AlternateContent xmlns:mc="http://schemas.openxmlformats.org/markup-compatibility/2006">
-        <mc:Choice xmlns:a14="http://schemas.microsoft.com/office/drawing/2010/main" Requires="a14">
+      <mc:AlternateContent xmlns:mc="http://schemas.openxmlformats.org/markup-compatibility/2006" xmlns:a14="http://schemas.microsoft.com/office/drawing/2010/main">
+        <mc:Choice Requires="a14">
           <p:sp>
             <p:nvSpPr>
               <p:cNvPr id="136" name="TextShape 2">
@@ -18375,7 +18435,7 @@
                     <m:f>
                       <m:fPr>
                         <m:ctrlPr>
-                          <a:rPr lang="fr-FR" sz="2400" spc="-1" dirty="0" smtClean="0">
+                          <a:rPr lang="fr-FR" sz="2400" i="1" spc="-1" dirty="0" smtClean="0">
                             <a:solidFill>
                               <a:srgbClr val="376092"/>
                             </a:solidFill>
@@ -18387,7 +18447,7 @@
                         <m:sSup>
                           <m:sSupPr>
                             <m:ctrlPr>
-                              <a:rPr lang="fr-FR" sz="2400" spc="-1" dirty="0" smtClean="0">
+                              <a:rPr lang="fr-FR" sz="2400" i="1" spc="-1" dirty="0" smtClean="0">
                                 <a:solidFill>
                                   <a:srgbClr val="376092"/>
                                 </a:solidFill>
@@ -18665,7 +18725,7 @@
             </p:txBody>
           </p:sp>
         </mc:Choice>
-        <mc:Fallback>
+        <mc:Fallback xmlns="">
           <p:sp>
             <p:nvSpPr>
               <p:cNvPr id="136" name="TextShape 2">
@@ -18741,7 +18801,7 @@
           <a:graphicData uri="http://schemas.openxmlformats.org/presentationml/2006/ole">
             <mc:AlternateContent xmlns:mc="http://schemas.openxmlformats.org/markup-compatibility/2006">
               <mc:Choice xmlns:v="urn:schemas-microsoft-com:vml" Requires="v">
-                <p:oleObj spid="_x0000_s4106" name="Worksheet" r:id="rId4" imgW="14849435" imgH="1638196" progId="Excel.Sheet.12">
+                <p:oleObj name="Worksheet" r:id="rId4" imgW="14849435" imgH="1638196" progId="Excel.Sheet.12">
                   <p:embed/>
                 </p:oleObj>
               </mc:Choice>

</xml_diff>